<commit_message>
Included comments to the proposed concept
</commit_message>
<xml_diff>
--- a/concepts/diagrams/InteractionOfServices.pptx
+++ b/concepts/diagrams/InteractionOfServices.pptx
@@ -112,6 +112,169 @@
 </p:presentation>
 </file>
 
+<file path=ppt/authors.xml><?xml version="1.0" encoding="utf-8"?>
+<p188:authorLst xmlns:a="http://schemas.openxmlformats.org/drawingml/2006/main" xmlns:r="http://schemas.openxmlformats.org/officeDocument/2006/relationships" xmlns:p188="http://schemas.microsoft.com/office/powerpoint/2018/8/main">
+  <p188:author id="{3067F8CD-2D8B-E02C-435C-7FEE036FC997}" name="Prathiba Jeevan (External)" initials="PJ" userId="S::prathiba.jeevan.external@telefonica.com::e3ff8f9f-a367-4d27-9bd4-84433ca974f5" providerId="AD"/>
+</p188:authorLst>
+</file>
+
+<file path=ppt/comments/modernComment_116_973288BB.xml><?xml version="1.0" encoding="utf-8"?>
+<p188:cmLst xmlns:a="http://schemas.openxmlformats.org/drawingml/2006/main" xmlns:r="http://schemas.openxmlformats.org/officeDocument/2006/relationships" xmlns:p188="http://schemas.microsoft.com/office/powerpoint/2018/8/main">
+  <p188:cm id="{65DF29A4-030A-40D4-A535-2E554BA81109}" authorId="{3067F8CD-2D8B-E02C-435C-7FEE036FC997}" created="2025-03-05T16:17:50.266">
+    <ac:deMkLst xmlns:ac="http://schemas.microsoft.com/office/drawing/2013/main/command">
+      <pc:docMk xmlns:pc="http://schemas.microsoft.com/office/powerpoint/2013/main/command"/>
+      <pc:sldMk xmlns:pc="http://schemas.microsoft.com/office/powerpoint/2013/main/command" cId="2536671419" sldId="278"/>
+      <ac:spMk id="9" creationId="{229884F1-1C12-104D-C37A-E8F9AAC43620}"/>
+    </ac:deMkLst>
+    <p188:txBody>
+      <a:bodyPr/>
+      <a:lstStyle/>
+      <a:p>
+        <a:r>
+          <a:rPr lang="de-DE"/>
+          <a:t>New requirement : 
+New API /v1/notify-me-about-new-netconf-interfaces needs to be supported 
+along with a invariant-process-snippet callback</a:t>
+        </a:r>
+      </a:p>
+    </p188:txBody>
+  </p188:cm>
+  <p188:cm id="{E0643B63-4056-4D66-9ED0-0394071F46AD}" authorId="{3067F8CD-2D8B-E02C-435C-7FEE036FC997}" created="2025-03-05T16:18:30.043">
+    <ac:deMkLst xmlns:ac="http://schemas.microsoft.com/office/drawing/2013/main/command">
+      <pc:docMk xmlns:pc="http://schemas.microsoft.com/office/powerpoint/2013/main/command"/>
+      <pc:sldMk xmlns:pc="http://schemas.microsoft.com/office/powerpoint/2013/main/command" cId="2536671419" sldId="278"/>
+      <ac:spMk id="13" creationId="{0870663B-C73A-4771-A211-4239452F5C6F}"/>
+    </ac:deMkLst>
+    <p188:txBody>
+      <a:bodyPr/>
+      <a:lstStyle/>
+      <a:p>
+        <a:r>
+          <a:rPr lang="de-DE"/>
+          <a:t>Change to the existing requirement : 
+Currently , we planned to send the response immediately. 
+We need to enhance the existing specification.</a:t>
+        </a:r>
+      </a:p>
+    </p188:txBody>
+  </p188:cm>
+  <p188:cm id="{014517AD-1968-4B48-ADFE-826BF58DF848}" authorId="{3067F8CD-2D8B-E02C-435C-7FEE036FC997}" created="2025-03-05T16:18:43.232">
+    <ac:deMkLst xmlns:ac="http://schemas.microsoft.com/office/drawing/2013/main/command">
+      <pc:docMk xmlns:pc="http://schemas.microsoft.com/office/powerpoint/2013/main/command"/>
+      <pc:sldMk xmlns:pc="http://schemas.microsoft.com/office/powerpoint/2013/main/command" cId="2536671419" sldId="278"/>
+      <ac:spMk id="39" creationId="{0A919349-A95E-3FB9-AA37-0D6D48B0754E}"/>
+    </ac:deMkLst>
+    <p188:txBody>
+      <a:bodyPr/>
+      <a:lstStyle/>
+      <a:p>
+        <a:r>
+          <a:rPr lang="de-DE"/>
+          <a:t>New requirement : 
+A cyclic process shall be introduced as a consequence of the "embed-yourself".
+Currently , when a mediator vm's engineering-limit gets lowered, then that number of instances above the engineering limits will be deleted. So , the "re-allocation" process is a new requirement.</a:t>
+        </a:r>
+      </a:p>
+    </p188:txBody>
+  </p188:cm>
+  <p188:cm id="{D3394C60-029E-4DAD-B8C1-EB7BA0F930CE}" authorId="{3067F8CD-2D8B-E02C-435C-7FEE036FC997}" created="2025-03-05T16:19:12.632">
+    <ac:deMkLst xmlns:ac="http://schemas.microsoft.com/office/drawing/2013/main/command">
+      <pc:docMk xmlns:pc="http://schemas.microsoft.com/office/powerpoint/2013/main/command"/>
+      <pc:sldMk xmlns:pc="http://schemas.microsoft.com/office/powerpoint/2013/main/command" cId="2536671419" sldId="278"/>
+      <ac:spMk id="39" creationId="{0A919349-A95E-3FB9-AA37-0D6D48B0754E}"/>
+    </ac:deMkLst>
+    <p188:txBody>
+      <a:bodyPr/>
+      <a:lstStyle/>
+      <a:p>
+        <a:r>
+          <a:rPr lang="de-DE"/>
+          <a:t>Modification to the existing specification :
+Currently , as a part of the "create-mediator-vm-template" , if the "engineering-limit" is lowered , then the number of instances above that limit shall be deleted. This behavior needs to be modified.</a:t>
+        </a:r>
+      </a:p>
+    </p188:txBody>
+  </p188:cm>
+  <p188:cm id="{4E839D1D-976D-4FC2-B104-92638BB93C02}" authorId="{3067F8CD-2D8B-E02C-435C-7FEE036FC997}" created="2025-03-05T16:19:35.673">
+    <ac:deMkLst xmlns:ac="http://schemas.microsoft.com/office/drawing/2013/main/command">
+      <pc:docMk xmlns:pc="http://schemas.microsoft.com/office/powerpoint/2013/main/command"/>
+      <pc:sldMk xmlns:pc="http://schemas.microsoft.com/office/powerpoint/2013/main/command" cId="2536671419" sldId="278"/>
+      <ac:spMk id="56" creationId="{9EBFEA2E-B45C-8A04-7DFE-5C0D54E2AEC3}"/>
+    </ac:deMkLst>
+    <p188:txBody>
+      <a:bodyPr/>
+      <a:lstStyle/>
+      <a:p>
+        <a:r>
+          <a:rPr lang="de-DE"/>
+          <a:t>New requirement : 
+Usually disregarding a instance will result in deleting that instance’s LTP stack from the LTP list in the Config File. Here “Mark affected mediatorVm to be deprecated” means , we will not delete that instance , instead we will mark the "operational-state" of the operation-client of MIM as Deprecated ?</a:t>
+        </a:r>
+      </a:p>
+    </p188:txBody>
+  </p188:cm>
+  <p188:cm id="{09132071-3AAA-424E-8787-E1BF47F75373}" authorId="{3067F8CD-2D8B-E02C-435C-7FEE036FC997}" created="2025-03-05T16:20:19.456">
+    <ac:deMkLst xmlns:ac="http://schemas.microsoft.com/office/drawing/2013/main/command">
+      <pc:docMk xmlns:pc="http://schemas.microsoft.com/office/powerpoint/2013/main/command"/>
+      <pc:sldMk xmlns:pc="http://schemas.microsoft.com/office/powerpoint/2013/main/command" cId="2536671419" sldId="278"/>
+      <ac:spMk id="125" creationId="{1FE31B48-04FF-C298-6453-7225A40DA40D}"/>
+    </ac:deMkLst>
+    <p188:txBody>
+      <a:bodyPr/>
+      <a:lstStyle/>
+      <a:p>
+        <a:r>
+          <a:rPr lang="de-DE"/>
+          <a:t>Clarification :
+1st line : Whether MM/NIM needs to be complemented with an operation-client of MO's API that provides the list the mount-names and its device-ip?
+overall : Whether a /v1/disregard-netconf-interface service will be exposed by MO ? Because , as per this diagram , MM/NIM itself  decides to dismantle mediator process. Whether that should also be notified to MO ?</a:t>
+        </a:r>
+      </a:p>
+    </p188:txBody>
+  </p188:cm>
+  <p188:cm id="{FDC29E76-1B9A-4CD1-89E0-A22C58FEE157}" authorId="{3067F8CD-2D8B-E02C-435C-7FEE036FC997}" created="2025-03-05T16:20:35.140">
+    <ac:deMkLst xmlns:ac="http://schemas.microsoft.com/office/drawing/2013/main/command">
+      <pc:docMk xmlns:pc="http://schemas.microsoft.com/office/powerpoint/2013/main/command"/>
+      <pc:sldMk xmlns:pc="http://schemas.microsoft.com/office/powerpoint/2013/main/command" cId="2536671419" sldId="278"/>
+      <ac:spMk id="225" creationId="{8778D23D-E927-DABD-0332-D93807833FA4}"/>
+    </ac:deMkLst>
+    <p188:txBody>
+      <a:bodyPr/>
+      <a:lstStyle/>
+      <a:p>
+        <a:r>
+          <a:rPr lang="de-DE"/>
+          <a:t>New requirement : 
+retention period concept is a new requirement.
+Clarification :
+I hope the logic is "IF mediatorVmProcess is not responsive on netconf
+THEN set firstSilenceDate=‚‘
+ELSE check firstSilenceDate
+" </a:t>
+        </a:r>
+      </a:p>
+    </p188:txBody>
+  </p188:cm>
+  <p188:cm id="{70D6D539-FE88-4B03-A757-FBCA94E5FE54}" authorId="{3067F8CD-2D8B-E02C-435C-7FEE036FC997}" created="2025-03-05T16:20:50.222">
+    <ac:deMkLst xmlns:ac="http://schemas.microsoft.com/office/drawing/2013/main/command">
+      <pc:docMk xmlns:pc="http://schemas.microsoft.com/office/powerpoint/2013/main/command"/>
+      <pc:sldMk xmlns:pc="http://schemas.microsoft.com/office/powerpoint/2013/main/command" cId="2536671419" sldId="278"/>
+      <ac:spMk id="104" creationId="{6181BD8D-E00F-C65B-E014-B40604A43C3E}"/>
+    </ac:deMkLst>
+    <p188:txBody>
+      <a:bodyPr/>
+      <a:lstStyle/>
+      <a:p>
+        <a:r>
+          <a:rPr lang="de-DE"/>
+          <a:t>Further information shall be helpful to know about this component.</a:t>
+        </a:r>
+      </a:p>
+    </p188:txBody>
+  </p188:cm>
+</p188:cmLst>
+</file>
+
 <file path=ppt/slideLayouts/slideLayout1.xml><?xml version="1.0" encoding="utf-8"?>
 <p:sldLayout xmlns:a="http://schemas.openxmlformats.org/drawingml/2006/main" xmlns:r="http://schemas.openxmlformats.org/officeDocument/2006/relationships" xmlns:p="http://schemas.openxmlformats.org/presentationml/2006/main" type="title" preserve="1">
   <p:cSld name="Titelfolie">
@@ -243,7 +406,7 @@
           <a:p>
             <a:fld id="{9A2764DB-E7DF-4EA7-A1AF-05A77C280FCA}" type="datetimeFigureOut">
               <a:rPr lang="de-DE" smtClean="0"/>
-              <a:t>28.02.2025</a:t>
+              <a:t>05.03.2025</a:t>
             </a:fld>
             <a:endParaRPr lang="de-DE"/>
           </a:p>
@@ -285,7 +448,7 @@
           <a:p>
             <a:fld id="{F0A02A80-A104-426B-9779-D7499AE27B60}" type="slidenum">
               <a:rPr lang="de-DE" smtClean="0"/>
-              <a:t>‹Nr.›</a:t>
+              <a:t>‹#›</a:t>
             </a:fld>
             <a:endParaRPr lang="de-DE"/>
           </a:p>
@@ -413,7 +576,7 @@
           <a:p>
             <a:fld id="{9A2764DB-E7DF-4EA7-A1AF-05A77C280FCA}" type="datetimeFigureOut">
               <a:rPr lang="de-DE" smtClean="0"/>
-              <a:t>28.02.2025</a:t>
+              <a:t>05.03.2025</a:t>
             </a:fld>
             <a:endParaRPr lang="de-DE"/>
           </a:p>
@@ -455,7 +618,7 @@
           <a:p>
             <a:fld id="{F0A02A80-A104-426B-9779-D7499AE27B60}" type="slidenum">
               <a:rPr lang="de-DE" smtClean="0"/>
-              <a:t>‹Nr.›</a:t>
+              <a:t>‹#›</a:t>
             </a:fld>
             <a:endParaRPr lang="de-DE"/>
           </a:p>
@@ -593,7 +756,7 @@
           <a:p>
             <a:fld id="{9A2764DB-E7DF-4EA7-A1AF-05A77C280FCA}" type="datetimeFigureOut">
               <a:rPr lang="de-DE" smtClean="0"/>
-              <a:t>28.02.2025</a:t>
+              <a:t>05.03.2025</a:t>
             </a:fld>
             <a:endParaRPr lang="de-DE"/>
           </a:p>
@@ -635,7 +798,7 @@
           <a:p>
             <a:fld id="{F0A02A80-A104-426B-9779-D7499AE27B60}" type="slidenum">
               <a:rPr lang="de-DE" smtClean="0"/>
-              <a:t>‹Nr.›</a:t>
+              <a:t>‹#›</a:t>
             </a:fld>
             <a:endParaRPr lang="de-DE"/>
           </a:p>
@@ -763,7 +926,7 @@
           <a:p>
             <a:fld id="{9A2764DB-E7DF-4EA7-A1AF-05A77C280FCA}" type="datetimeFigureOut">
               <a:rPr lang="de-DE" smtClean="0"/>
-              <a:t>28.02.2025</a:t>
+              <a:t>05.03.2025</a:t>
             </a:fld>
             <a:endParaRPr lang="de-DE"/>
           </a:p>
@@ -805,7 +968,7 @@
           <a:p>
             <a:fld id="{F0A02A80-A104-426B-9779-D7499AE27B60}" type="slidenum">
               <a:rPr lang="de-DE" smtClean="0"/>
-              <a:t>‹Nr.›</a:t>
+              <a:t>‹#›</a:t>
             </a:fld>
             <a:endParaRPr lang="de-DE"/>
           </a:p>
@@ -1009,7 +1172,7 @@
           <a:p>
             <a:fld id="{9A2764DB-E7DF-4EA7-A1AF-05A77C280FCA}" type="datetimeFigureOut">
               <a:rPr lang="de-DE" smtClean="0"/>
-              <a:t>28.02.2025</a:t>
+              <a:t>05.03.2025</a:t>
             </a:fld>
             <a:endParaRPr lang="de-DE"/>
           </a:p>
@@ -1051,7 +1214,7 @@
           <a:p>
             <a:fld id="{F0A02A80-A104-426B-9779-D7499AE27B60}" type="slidenum">
               <a:rPr lang="de-DE" smtClean="0"/>
-              <a:t>‹Nr.›</a:t>
+              <a:t>‹#›</a:t>
             </a:fld>
             <a:endParaRPr lang="de-DE"/>
           </a:p>
@@ -1241,7 +1404,7 @@
           <a:p>
             <a:fld id="{9A2764DB-E7DF-4EA7-A1AF-05A77C280FCA}" type="datetimeFigureOut">
               <a:rPr lang="de-DE" smtClean="0"/>
-              <a:t>28.02.2025</a:t>
+              <a:t>05.03.2025</a:t>
             </a:fld>
             <a:endParaRPr lang="de-DE"/>
           </a:p>
@@ -1283,7 +1446,7 @@
           <a:p>
             <a:fld id="{F0A02A80-A104-426B-9779-D7499AE27B60}" type="slidenum">
               <a:rPr lang="de-DE" smtClean="0"/>
-              <a:t>‹Nr.›</a:t>
+              <a:t>‹#›</a:t>
             </a:fld>
             <a:endParaRPr lang="de-DE"/>
           </a:p>
@@ -1608,7 +1771,7 @@
           <a:p>
             <a:fld id="{9A2764DB-E7DF-4EA7-A1AF-05A77C280FCA}" type="datetimeFigureOut">
               <a:rPr lang="de-DE" smtClean="0"/>
-              <a:t>28.02.2025</a:t>
+              <a:t>05.03.2025</a:t>
             </a:fld>
             <a:endParaRPr lang="de-DE"/>
           </a:p>
@@ -1650,7 +1813,7 @@
           <a:p>
             <a:fld id="{F0A02A80-A104-426B-9779-D7499AE27B60}" type="slidenum">
               <a:rPr lang="de-DE" smtClean="0"/>
-              <a:t>‹Nr.›</a:t>
+              <a:t>‹#›</a:t>
             </a:fld>
             <a:endParaRPr lang="de-DE"/>
           </a:p>
@@ -1726,7 +1889,7 @@
           <a:p>
             <a:fld id="{9A2764DB-E7DF-4EA7-A1AF-05A77C280FCA}" type="datetimeFigureOut">
               <a:rPr lang="de-DE" smtClean="0"/>
-              <a:t>28.02.2025</a:t>
+              <a:t>05.03.2025</a:t>
             </a:fld>
             <a:endParaRPr lang="de-DE"/>
           </a:p>
@@ -1768,7 +1931,7 @@
           <a:p>
             <a:fld id="{F0A02A80-A104-426B-9779-D7499AE27B60}" type="slidenum">
               <a:rPr lang="de-DE" smtClean="0"/>
-              <a:t>‹Nr.›</a:t>
+              <a:t>‹#›</a:t>
             </a:fld>
             <a:endParaRPr lang="de-DE"/>
           </a:p>
@@ -1821,7 +1984,7 @@
           <a:p>
             <a:fld id="{9A2764DB-E7DF-4EA7-A1AF-05A77C280FCA}" type="datetimeFigureOut">
               <a:rPr lang="de-DE" smtClean="0"/>
-              <a:t>28.02.2025</a:t>
+              <a:t>05.03.2025</a:t>
             </a:fld>
             <a:endParaRPr lang="de-DE"/>
           </a:p>
@@ -1863,7 +2026,7 @@
           <a:p>
             <a:fld id="{F0A02A80-A104-426B-9779-D7499AE27B60}" type="slidenum">
               <a:rPr lang="de-DE" smtClean="0"/>
-              <a:t>‹Nr.›</a:t>
+              <a:t>‹#›</a:t>
             </a:fld>
             <a:endParaRPr lang="de-DE"/>
           </a:p>
@@ -2098,7 +2261,7 @@
           <a:p>
             <a:fld id="{9A2764DB-E7DF-4EA7-A1AF-05A77C280FCA}" type="datetimeFigureOut">
               <a:rPr lang="de-DE" smtClean="0"/>
-              <a:t>28.02.2025</a:t>
+              <a:t>05.03.2025</a:t>
             </a:fld>
             <a:endParaRPr lang="de-DE"/>
           </a:p>
@@ -2140,7 +2303,7 @@
           <a:p>
             <a:fld id="{F0A02A80-A104-426B-9779-D7499AE27B60}" type="slidenum">
               <a:rPr lang="de-DE" smtClean="0"/>
-              <a:t>‹Nr.›</a:t>
+              <a:t>‹#›</a:t>
             </a:fld>
             <a:endParaRPr lang="de-DE"/>
           </a:p>
@@ -2355,7 +2518,7 @@
           <a:p>
             <a:fld id="{9A2764DB-E7DF-4EA7-A1AF-05A77C280FCA}" type="datetimeFigureOut">
               <a:rPr lang="de-DE" smtClean="0"/>
-              <a:t>28.02.2025</a:t>
+              <a:t>05.03.2025</a:t>
             </a:fld>
             <a:endParaRPr lang="de-DE"/>
           </a:p>
@@ -2397,7 +2560,7 @@
           <a:p>
             <a:fld id="{F0A02A80-A104-426B-9779-D7499AE27B60}" type="slidenum">
               <a:rPr lang="de-DE" smtClean="0"/>
-              <a:t>‹Nr.›</a:t>
+              <a:t>‹#›</a:t>
             </a:fld>
             <a:endParaRPr lang="de-DE"/>
           </a:p>
@@ -2568,7 +2731,7 @@
           <a:p>
             <a:fld id="{9A2764DB-E7DF-4EA7-A1AF-05A77C280FCA}" type="datetimeFigureOut">
               <a:rPr lang="de-DE" smtClean="0"/>
-              <a:t>28.02.2025</a:t>
+              <a:t>05.03.2025</a:t>
             </a:fld>
             <a:endParaRPr lang="de-DE"/>
           </a:p>
@@ -2646,7 +2809,7 @@
           <a:p>
             <a:fld id="{F0A02A80-A104-426B-9779-D7499AE27B60}" type="slidenum">
               <a:rPr lang="de-DE" smtClean="0"/>
-              <a:t>‹Nr.›</a:t>
+              <a:t>‹#›</a:t>
             </a:fld>
             <a:endParaRPr lang="de-DE"/>
           </a:p>
@@ -3813,7 +3976,7 @@
           <p:nvPr/>
         </p:nvPicPr>
         <p:blipFill>
-          <a:blip r:embed="rId2"/>
+          <a:blip r:embed="rId3"/>
           <a:stretch>
             <a:fillRect/>
           </a:stretch>
@@ -3843,7 +4006,7 @@
           <p:nvPr/>
         </p:nvPicPr>
         <p:blipFill>
-          <a:blip r:embed="rId3"/>
+          <a:blip r:embed="rId4"/>
           <a:stretch>
             <a:fillRect/>
           </a:stretch>
@@ -5697,7 +5860,7 @@
           <p:nvPr/>
         </p:nvPicPr>
         <p:blipFill>
-          <a:blip r:embed="rId2"/>
+          <a:blip r:embed="rId3"/>
           <a:stretch>
             <a:fillRect/>
           </a:stretch>
@@ -5772,6 +5935,11 @@
   <p:clrMapOvr>
     <a:masterClrMapping/>
   </p:clrMapOvr>
+  <p:extLst>
+    <p:ext uri="{6950BFC3-D8DA-4A85-94F7-54DA5524770B}">
+      <p188:commentRel xmlns:p188="http://schemas.microsoft.com/office/powerpoint/2018/8/main" r:id="rId2"/>
+    </p:ext>
+  </p:extLst>
 </p:sld>
 </file>
 

</xml_diff>